<commit_message>
docs: drop dead file:// footnote links from the rendered PDFs and stale image paths from the deck
</commit_message>
<xml_diff>
--- a/deck/We-the-Users-Launch-Deck.pptx
+++ b/deck/We-the-Users-Launch-Deck.pptx
@@ -8878,7 +8878,7 @@
       </p:sp>
       <p:pic>
         <p:nvPicPr>
-          <p:cNvPr id="7" name="Image 0" descr="/home/claude/work/wetheusers/deck/assets/cartoon-used.png">    </p:cNvPr>
+          <p:cNvPr id="7" name="Image 0" descr="assets/cartoon-used.png">    </p:cNvPr>
           <p:cNvPicPr>
             <a:picLocks noChangeAspect="1"/>
           </p:cNvPicPr>
@@ -10541,7 +10541,7 @@
       </p:sp>
       <p:pic>
         <p:nvPicPr>
-          <p:cNvPr id="7" name="Image 0" descr="/home/claude/work/wetheusers/deck/assets/cartoon-users.png">    </p:cNvPr>
+          <p:cNvPr id="7" name="Image 0" descr="assets/cartoon-users.png">    </p:cNvPr>
           <p:cNvPicPr>
             <a:picLocks noChangeAspect="1"/>
           </p:cNvPicPr>

</xml_diff>